<commit_message>
Corrige el título del trabajo
Título: Metaanálisis del desempeño de la predicción espacial de variables
ambientales mediante geoestadística y aprendizaje automático en regiones
montañosas. Se actualiza en el artículo, la presentación, el informe
consolidado y el README.
</commit_message>
<xml_diff>
--- a/articulo_ieee/presentacion.pptx
+++ b/articulo_ieee/presentacion.pptx
@@ -120,21 +120,21 @@
   <p:extLst>
     <p:ext uri="{521415D9-36F7-43E2-AB2F-B90AF26B5E84}">
       <p14:sectionLst xmlns:p14="http://schemas.microsoft.com/office/powerpoint/2010/main">
-        <p14:section name="Introducción" id="{863d3717-9a41-07a2-49ef-cb6a50d13bcd}">
+        <p14:section name="Introducción" id="{7f6a327e-c2ce-6cfc-b204-38861f137a27}">
           <p14:sldIdLst>
             <p14:sldId id="256"/>
             <p14:sldId id="257"/>
             <p14:sldId id="258"/>
           </p14:sldIdLst>
         </p14:section>
-        <p14:section name="Métodos" id="{b161ccb4-91e2-c93a-b0bf-63a9a7fb334c}">
+        <p14:section name="Métodos" id="{33675c48-33bc-8884-26fc-b7ea8d7bd8d3}">
           <p14:sldIdLst>
             <p14:sldId id="259"/>
             <p14:sldId id="260"/>
             <p14:sldId id="261"/>
           </p14:sldIdLst>
         </p14:section>
-        <p14:section name="Resultados" id="{887c2177-33f4-c464-3fc3-7e97e69928f4}">
+        <p14:section name="Resultados" id="{2c5121e0-24f7-979a-682d-4dcb77d80cab}">
           <p14:sldIdLst>
             <p14:sldId id="262"/>
             <p14:sldId id="263"/>
@@ -143,13 +143,13 @@
             <p14:sldId id="266"/>
           </p14:sldIdLst>
         </p14:section>
-        <p14:section name="Discusión" id="{41aeccce-32e4-f982-c6bc-564ee3d3f164}">
+        <p14:section name="Discusión" id="{7d003f84-2e3f-37ed-d6b5-a71ad8087590}">
           <p14:sldIdLst>
             <p14:sldId id="267"/>
             <p14:sldId id="268"/>
           </p14:sldIdLst>
         </p14:section>
-        <p14:section name="Conclusiones" id="{12463cc3-dddf-5cc1-12af-eb81b1bc727b}">
+        <p14:section name="Conclusiones" id="{a4fd9636-5040-6631-6c31-6a97cf6add20}">
           <p14:sldIdLst>
             <p14:sldId id="269"/>
           </p14:sldIdLst>
@@ -2957,8 +2957,8 @@
         </p:nvSpPr>
         <p:spPr>
           <a:xfrm>
-            <a:off x="731520" y="1554480"/>
-            <a:ext cx="10698480" cy="2011680"/>
+            <a:off x="731520" y="1005840"/>
+            <a:ext cx="10698480" cy="2560320"/>
           </a:xfrm>
           <a:prstGeom prst="rect">
             <a:avLst/>
@@ -2971,7 +2971,7 @@
           <a:lstStyle>
             <a:lvl1pPr indent="0" marL="0">
               <a:buNone/>
-              <a:defRPr lang="en-US" sz="3800" b="1" dirty="0">
+              <a:defRPr lang="en-US" sz="3400" b="1" dirty="0">
                 <a:solidFill>
                   <a:schemeClr val="bg1"/>
                 </a:solidFill>
@@ -2985,7 +2985,7 @@
             <a:pPr indent="0" marL="0">
               <a:buNone/>
             </a:pPr>
-            <a:endParaRPr lang="en-US" sz="3800" dirty="0"/>
+            <a:endParaRPr lang="en-US" sz="3400" dirty="0"/>
           </a:p>
         </p:txBody>
       </p:sp>
@@ -3135,7 +3135,7 @@
                 <a:ea typeface="Calibri" pitchFamily="34" charset="-122"/>
                 <a:cs typeface="Calibri" pitchFamily="34" charset="-120"/>
               </a:rPr>
-              <a:t>Geoestadística vs. AA en montaña · UNA Puno 2026</a:t>
+              <a:t>Metaanálisis de la predicción espacial en montaña · UNA Puno 2026</a:t>
             </a:r>
             <a:endParaRPr lang="en-US" sz="1000" dirty="0"/>
           </a:p>
@@ -3665,8 +3665,8 @@
         </p:nvSpPr>
         <p:spPr>
           <a:xfrm>
-            <a:off x="731520" y="1554480"/>
-            <a:ext cx="10698480" cy="2011680"/>
+            <a:off x="731520" y="1005840"/>
+            <a:ext cx="10698480" cy="2560320"/>
           </a:xfrm>
           <a:prstGeom prst="rect">
             <a:avLst/>
@@ -3682,7 +3682,7 @@
               <a:buNone/>
             </a:pPr>
             <a:r>
-              <a:rPr lang="en-US" sz="3800" b="1" dirty="0">
+              <a:rPr lang="en-US" sz="3400" b="1" dirty="0">
                 <a:solidFill>
                   <a:schemeClr val="bg1"/>
                 </a:solidFill>
@@ -3690,9 +3690,9 @@
                 <a:ea typeface="Cambria" pitchFamily="34" charset="-122"/>
                 <a:cs typeface="Cambria" pitchFamily="34" charset="-120"/>
               </a:rPr>
-              <a:t>Geoestadística frente a aprendizaje automático para predecir precipitación y temperatura en regiones montañosas</a:t>
-            </a:r>
-            <a:endParaRPr lang="en-US" sz="3800" dirty="0"/>
+              <a:t>Metaanálisis del desempeño de la predicción espacial de variables ambientales mediante geoestadística y aprendizaje automático en regiones montañosas</a:t>
+            </a:r>
+            <a:endParaRPr lang="en-US" sz="3400" dirty="0"/>
           </a:p>
         </p:txBody>
       </p:sp>

</xml_diff>

<commit_message>
Corrige la presentación dañada: flecha con ancho negativo en el PRISMA
La flecha de la búsqueda complementaria se escribía con un ancho negativo,
que el formato .pptx no admite y hacía que PowerPoint marcara el archivo
como dañado. Ahora se dibuja en una caja de tamaño positivo y se voltea.
</commit_message>
<xml_diff>
--- a/articulo_ieee/presentacion.pptx
+++ b/articulo_ieee/presentacion.pptx
@@ -120,21 +120,21 @@
   <p:extLst>
     <p:ext uri="{521415D9-36F7-43E2-AB2F-B90AF26B5E84}">
       <p14:sectionLst xmlns:p14="http://schemas.microsoft.com/office/powerpoint/2010/main">
-        <p14:section name="Introducción" id="{7f6a327e-c2ce-6cfc-b204-38861f137a27}">
+        <p14:section name="Introducción" id="{141d1d9a-0536-284e-fcf9-2091f5e5f2e8}">
           <p14:sldIdLst>
             <p14:sldId id="256"/>
             <p14:sldId id="257"/>
             <p14:sldId id="258"/>
           </p14:sldIdLst>
         </p14:section>
-        <p14:section name="Métodos" id="{33675c48-33bc-8884-26fc-b7ea8d7bd8d3}">
+        <p14:section name="Métodos" id="{dcdeb1bf-e9f6-8ca3-c96d-6c975f71ed42}">
           <p14:sldIdLst>
             <p14:sldId id="259"/>
             <p14:sldId id="260"/>
             <p14:sldId id="261"/>
           </p14:sldIdLst>
         </p14:section>
-        <p14:section name="Resultados" id="{2c5121e0-24f7-979a-682d-4dcb77d80cab}">
+        <p14:section name="Resultados" id="{4c7aabc6-ac46-f62a-7276-18ac0a5fa862}">
           <p14:sldIdLst>
             <p14:sldId id="262"/>
             <p14:sldId id="263"/>
@@ -143,13 +143,13 @@
             <p14:sldId id="266"/>
           </p14:sldIdLst>
         </p14:section>
-        <p14:section name="Discusión" id="{7d003f84-2e3f-37ed-d6b5-a71ad8087590}">
+        <p14:section name="Discusión" id="{8b38eb4b-158b-82a1-0a20-3252c4e91bde}">
           <p14:sldIdLst>
             <p14:sldId id="267"/>
             <p14:sldId id="268"/>
           </p14:sldIdLst>
         </p14:section>
-        <p14:section name="Conclusiones" id="{a4fd9636-5040-6631-6c31-6a97cf6add20}">
+        <p14:section name="Conclusiones" id="{cdd42fb5-c491-e410-cd2a-7aa234df5a58}">
           <p14:sldIdLst>
             <p14:sldId id="269"/>
           </p14:sldIdLst>
@@ -9208,9 +9208,9 @@
           <p:nvPr/>
         </p:nvSpPr>
         <p:spPr>
-          <a:xfrm>
-            <a:off x="5486400" y="3749040"/>
-            <a:ext cx="-731520" cy="457200"/>
+          <a:xfrm flipH="1">
+            <a:off x="4754880" y="3749040"/>
+            <a:ext cx="731520" cy="457200"/>
           </a:xfrm>
           <a:prstGeom prst="line">
             <a:avLst/>

</xml_diff>